<commit_message>
docs: update team details in solution challenge deck
</commit_message>
<xml_diff>
--- a/docs/SecureMedia_AI_Solution_Challenge_Deck.pptx
+++ b/docs/SecureMedia_AI_Solution_Challenge_Deck.pptx
@@ -18421,7 +18421,7 @@
                 </a:solidFill>
                 <a:latin typeface="Google Sans"/>
               </a:rPr>
-              <a:t>Team name: SecureMedia AI</a:t>
+              <a:t>Team name: double trouble 2x</a:t>
             </a:r>
           </a:p>
           <a:p>
@@ -18430,7 +18430,26 @@
                 <a:spcPts val="0"/>
               </a:spcBef>
               <a:spcAft>
-                <a:spcPts val="400"/>
+                <a:spcPts val="200"/>
+              </a:spcAft>
+            </a:pPr>
+            <a:r>
+              <a:rPr sz="1250" b="1" i="0">
+                <a:solidFill>
+                  <a:srgbClr val="202124"/>
+                </a:solidFill>
+                <a:latin typeface="Google Sans"/>
+              </a:rPr>
+              <a:t>Team members:</a:t>
+            </a:r>
+          </a:p>
+          <a:p>
+            <a:pPr algn="l">
+              <a:spcBef>
+                <a:spcPts val="0"/>
+              </a:spcBef>
+              <a:spcAft>
+                <a:spcPts val="200"/>
               </a:spcAft>
             </a:pPr>
             <a:r>
@@ -18440,7 +18459,26 @@
                 </a:solidFill>
                 <a:latin typeface="Google Sans"/>
               </a:rPr>
-              <a:t>Team leader name: Aadishah17</a:t>
+              <a:t>1) Aadi shah</a:t>
+            </a:r>
+          </a:p>
+          <a:p>
+            <a:pPr algn="l">
+              <a:spcBef>
+                <a:spcPts val="0"/>
+              </a:spcBef>
+              <a:spcAft>
+                <a:spcPts val="400"/>
+              </a:spcAft>
+            </a:pPr>
+            <a:r>
+              <a:rPr sz="1250" b="0" i="0">
+                <a:solidFill>
+                  <a:srgbClr val="202124"/>
+                </a:solidFill>
+                <a:latin typeface="Google Sans"/>
+              </a:rPr>
+              <a:t>2) nitya singh</a:t>
             </a:r>
           </a:p>
           <a:p>

</xml_diff>